<commit_message>
Switch the workshop to uv-only local runs.
Drop Docker/Codespaces extras so students start from uv, a free LLM key, and the dummy plant plus Open WebUI.

Co-authored-by: Cursor <cursoragent@cursor.com>
</commit_message>
<xml_diff>
--- a/slides/예지보전_에이전트_실습.pptx
+++ b/slides/예지보전_에이전트_실습.pptx
@@ -708,7 +708,7 @@
               <a:rPr sz="1200">
                 <a:latin typeface="NanumBarunGothic"/>
               </a:rPr>
-              <a:t>3분. pump-a-de만 기억하게.</a:t>
+              <a:t>3분. pump-a-de만 기억하게. 10개는 지도로 보여 준다.</a:t>
             </a:r>
           </a:p>
         </p:txBody>
@@ -1194,7 +1194,7 @@
               <a:rPr sz="1200">
                 <a:latin typeface="NanumBarunGothic"/>
               </a:rPr>
-              <a:t>5분. 도구 이름을 크게. 네 번째 도구를 즉석 제안하지 말 것.</a:t>
+              <a:t>5분. 조회와 변경을 갈라서. 실설비 변경이 아님을 한 번 더.</a:t>
             </a:r>
           </a:p>
         </p:txBody>
@@ -1437,7 +1437,7 @@
               <a:rPr sz="1200">
                 <a:latin typeface="NanumBarunGothic"/>
               </a:rPr>
-              <a:t>1–2분. 표를 손가락으로 가리키며 이론4가 가장 길다고 미리 선언. 실습은 Codespaces.</a:t>
+              <a:t>1–2분. 표를 손가락으로 가리키며 이론4가 가장 길다고 미리 선언. 실습은 uv.</a:t>
             </a:r>
           </a:p>
         </p:txBody>
@@ -1680,7 +1680,7 @@
               <a:rPr sz="1200">
                 <a:latin typeface="NanumBarunGothic"/>
               </a:rPr>
-              <a:t>4분. stop_pump가 없는 것이 설계다.</a:t>
+              <a:t>4분. 조회와 변경을 갈라 둔 것이 설계다. 실설비 버튼이 아님.</a:t>
             </a:r>
           </a:p>
         </p:txBody>
@@ -1842,7 +1842,7 @@
               <a:rPr sz="1200">
                 <a:latin typeface="NanumBarunGothic"/>
               </a:rPr>
-              <a:t>3분. 안전 한 장. 웃지 말 것.</a:t>
+              <a:t>3분. 오늘 이론의 한 장. 더미 버튼은 체감용, 실설비는 과함.</a:t>
             </a:r>
           </a:p>
         </p:txBody>
@@ -2409,7 +2409,7 @@
               <a:rPr sz="1200">
                 <a:latin typeface="NanumBarunGothic"/>
               </a:rPr>
-              <a:t>15분. 화면을 천천히. compose가 미리 넣었으면 토글만.</a:t>
+              <a:t>15분. 화면을 천천히. 타입이 Streamable HTTP인지 확인.</a:t>
             </a:r>
           </a:p>
         </p:txBody>
@@ -2490,7 +2490,7 @@
               <a:rPr sz="1200">
                 <a:latin typeface="NanumBarunGothic"/>
               </a:rPr>
-              <a:t>10분. 채점 기준: ID 세 개, 숫자 대조, 명령조 정지 없음.</a:t>
+              <a:t>10분. 채점 기준: 센서 10개 중 실명, 숫자 대조, 명령조 정지 없음.</a:t>
             </a:r>
           </a:p>
         </p:txBody>
@@ -6651,8 +6651,8 @@
                 <a:ea typeface="NanumBarunGothic"/>
                 <a:cs typeface="NanumBarunGothic"/>
               </a:rPr>
-              <a:t>도구 3개와 Markdown Skill.
-모델이 숫자를 발명하지 않게.</a:t>
+              <a:t>조회 vs 변경, Skill.
+에이전트가 과한 때를 가른다.</a:t>
             </a:r>
           </a:p>
         </p:txBody>
@@ -6824,7 +6824,7 @@
                 <a:ea typeface="NanumSquare"/>
                 <a:cs typeface="NanumSquare"/>
               </a:rPr>
-              <a:t>더미 진동 → MQTT</a:t>
+              <a:t>더미 공장 → SQLite</a:t>
             </a:r>
           </a:p>
         </p:txBody>
@@ -6866,7 +6866,7 @@
                 <a:cs typeface="NanumBarunGothic"/>
               </a:rPr>
               <a:t>MCP :8000  →  Open WebUI :8080
-Codespaces에서 그대로 기동.</a:t>
+MQTT 없음.</a:t>
             </a:r>
           </a:p>
         </p:txBody>
@@ -8062,7 +8062,7 @@
                 <a:ea typeface="NanumSquare"/>
                 <a:cs typeface="NanumSquare"/>
               </a:rPr>
-              <a:t>오늘 센서는 세 개뿐입니다</a:t>
+              <a:t>오늘은 설비 9대, 센서 10개의 가상 공장입니다</a:t>
             </a:r>
           </a:p>
         </p:txBody>
@@ -8121,7 +8121,7 @@
         <p:spPr>
           <a:xfrm>
             <a:off x="640080" y="1481328"/>
-            <a:ext cx="2651760" cy="320040"/>
+            <a:ext cx="3474720" cy="320040"/>
           </a:xfrm>
           <a:prstGeom prst="rect">
             <a:avLst/>
@@ -8148,7 +8148,7 @@
                 <a:ea typeface="NanumBarunGothic"/>
                 <a:cs typeface="NanumBarunGothic"/>
               </a:rPr>
-              <a:t>sensor_id</a:t>
+              <a:t>구역</a:t>
             </a:r>
           </a:p>
         </p:txBody>
@@ -8161,8 +8161,8 @@
         </p:nvSpPr>
         <p:spPr>
           <a:xfrm>
-            <a:off x="3383280" y="1481328"/>
-            <a:ext cx="2651760" cy="320040"/>
+            <a:off x="4297680" y="1481328"/>
+            <a:ext cx="3474720" cy="320040"/>
           </a:xfrm>
           <a:prstGeom prst="rect">
             <a:avLst/>
@@ -8189,7 +8189,7 @@
                 <a:ea typeface="NanumBarunGothic"/>
                 <a:cs typeface="NanumBarunGothic"/>
               </a:rPr>
-              <a:t>자산</a:t>
+              <a:t>sensor_id</a:t>
             </a:r>
           </a:p>
         </p:txBody>
@@ -8202,8 +8202,8 @@
         </p:nvSpPr>
         <p:spPr>
           <a:xfrm>
-            <a:off x="6126480" y="1481328"/>
-            <a:ext cx="2651760" cy="320040"/>
+            <a:off x="7955279" y="1481328"/>
+            <a:ext cx="3474720" cy="320040"/>
           </a:xfrm>
           <a:prstGeom prst="rect">
             <a:avLst/>
@@ -8230,47 +8230,6 @@
                 <a:ea typeface="NanumBarunGothic"/>
                 <a:cs typeface="NanumBarunGothic"/>
               </a:rPr>
-              <a:t>위치</a:t>
-            </a:r>
-          </a:p>
-        </p:txBody>
-      </p:sp>
-      <p:sp>
-        <p:nvSpPr>
-          <p:cNvPr id="10" name="TextBox 9"/>
-          <p:cNvSpPr txBox="1"/>
-          <p:nvPr/>
-        </p:nvSpPr>
-        <p:spPr>
-          <a:xfrm>
-            <a:off x="8869680" y="1481328"/>
-            <a:ext cx="2651760" cy="320040"/>
-          </a:xfrm>
-          <a:prstGeom prst="rect">
-            <a:avLst/>
-          </a:prstGeom>
-          <a:noFill/>
-        </p:spPr>
-        <p:txBody>
-          <a:bodyPr wrap="square">
-            <a:spAutoFit/>
-          </a:bodyPr>
-          <a:lstStyle/>
-          <a:p>
-            <a:pPr algn="l">
-              <a:spcAft>
-                <a:spcPts val="0"/>
-              </a:spcAft>
-            </a:pPr>
-            <a:r>
-              <a:rPr sz="1300" b="1">
-                <a:solidFill>
-                  <a:srgbClr val="22D3EE"/>
-                </a:solidFill>
-                <a:latin typeface="NanumBarunGothic"/>
-                <a:ea typeface="NanumBarunGothic"/>
-                <a:cs typeface="NanumBarunGothic"/>
-              </a:rPr>
               <a:t>역할</a:t>
             </a:r>
           </a:p>
@@ -8278,14 +8237,14 @@
       </p:sp>
       <p:sp>
         <p:nvSpPr>
-          <p:cNvPr id="11" name="Rounded Rectangle 10"/>
+          <p:cNvPr id="10" name="Rounded Rectangle 9"/>
           <p:cNvSpPr/>
           <p:nvPr/>
         </p:nvSpPr>
         <p:spPr>
           <a:xfrm>
             <a:off x="502920" y="1965960"/>
-            <a:ext cx="11155680" cy="777240"/>
+            <a:ext cx="11155680" cy="658368"/>
           </a:xfrm>
           <a:prstGeom prst="roundRect">
             <a:avLst>
@@ -8325,14 +8284,14 @@
       </p:sp>
       <p:sp>
         <p:nvSpPr>
-          <p:cNvPr id="12" name="TextBox 11"/>
-          <p:cNvSpPr txBox="1"/>
-          <p:nvPr/>
-        </p:nvSpPr>
-        <p:spPr>
-          <a:xfrm>
-            <a:off x="640080" y="2167128"/>
-            <a:ext cx="2651760" cy="411480"/>
+          <p:cNvPr id="11" name="TextBox 10"/>
+          <p:cNvSpPr txBox="1"/>
+          <p:nvPr/>
+        </p:nvSpPr>
+        <p:spPr>
+          <a:xfrm>
+            <a:off x="640080" y="2130552"/>
+            <a:ext cx="3474720" cy="411480"/>
           </a:xfrm>
           <a:prstGeom prst="rect">
             <a:avLst/>
@@ -8359,21 +8318,21 @@
                 <a:ea typeface="NanumBarunGothic"/>
                 <a:cs typeface="NanumBarunGothic"/>
               </a:rPr>
-              <a:t>pump-a-de</a:t>
-            </a:r>
-          </a:p>
-        </p:txBody>
-      </p:sp>
-      <p:sp>
-        <p:nvSpPr>
-          <p:cNvPr id="13" name="TextBox 12"/>
-          <p:cNvSpPr txBox="1"/>
-          <p:nvPr/>
-        </p:nvSpPr>
-        <p:spPr>
-          <a:xfrm>
-            <a:off x="3383280" y="2167128"/>
-            <a:ext cx="2651760" cy="411480"/>
+              <a:t>펌프실</a:t>
+            </a:r>
+          </a:p>
+        </p:txBody>
+      </p:sp>
+      <p:sp>
+        <p:nvSpPr>
+          <p:cNvPr id="12" name="TextBox 11"/>
+          <p:cNvSpPr txBox="1"/>
+          <p:nvPr/>
+        </p:nvSpPr>
+        <p:spPr>
+          <a:xfrm>
+            <a:off x="4297680" y="2130552"/>
+            <a:ext cx="3474720" cy="411480"/>
           </a:xfrm>
           <a:prstGeom prst="rect">
             <a:avLst/>
@@ -8400,21 +8359,21 @@
                 <a:ea typeface="NanumBarunGothic"/>
                 <a:cs typeface="NanumBarunGothic"/>
               </a:rPr>
-              <a:t>냉각수 펌프 A</a:t>
-            </a:r>
-          </a:p>
-        </p:txBody>
-      </p:sp>
-      <p:sp>
-        <p:nvSpPr>
-          <p:cNvPr id="14" name="TextBox 13"/>
-          <p:cNvSpPr txBox="1"/>
-          <p:nvPr/>
-        </p:nvSpPr>
-        <p:spPr>
-          <a:xfrm>
-            <a:off x="6126480" y="2167128"/>
-            <a:ext cx="2651760" cy="411480"/>
+              <a:t>pump-a-de / pump-a-nde</a:t>
+            </a:r>
+          </a:p>
+        </p:txBody>
+      </p:sp>
+      <p:sp>
+        <p:nvSpPr>
+          <p:cNvPr id="13" name="TextBox 12"/>
+          <p:cNvSpPr txBox="1"/>
+          <p:nvPr/>
+        </p:nvSpPr>
+        <p:spPr>
+          <a:xfrm>
+            <a:off x="7955279" y="2130552"/>
+            <a:ext cx="3474720" cy="411480"/>
           </a:xfrm>
           <a:prstGeom prst="rect">
             <a:avLst/>
@@ -8441,47 +8400,6 @@
                 <a:ea typeface="NanumBarunGothic"/>
                 <a:cs typeface="NanumBarunGothic"/>
               </a:rPr>
-              <a:t>구동측 베어링</a:t>
-            </a:r>
-          </a:p>
-        </p:txBody>
-      </p:sp>
-      <p:sp>
-        <p:nvSpPr>
-          <p:cNvPr id="15" name="TextBox 14"/>
-          <p:cNvSpPr txBox="1"/>
-          <p:nvPr/>
-        </p:nvSpPr>
-        <p:spPr>
-          <a:xfrm>
-            <a:off x="8869680" y="2167128"/>
-            <a:ext cx="2651760" cy="411480"/>
-          </a:xfrm>
-          <a:prstGeom prst="rect">
-            <a:avLst/>
-          </a:prstGeom>
-          <a:noFill/>
-        </p:spPr>
-        <p:txBody>
-          <a:bodyPr wrap="square">
-            <a:spAutoFit/>
-          </a:bodyPr>
-          <a:lstStyle/>
-          <a:p>
-            <a:pPr algn="l">
-              <a:spcAft>
-                <a:spcPts val="0"/>
-              </a:spcAft>
-            </a:pPr>
-            <a:r>
-              <a:rPr sz="1500" b="0">
-                <a:solidFill>
-                  <a:srgbClr val="F8FAFC"/>
-                </a:solidFill>
-                <a:latin typeface="NanumBarunGothic"/>
-                <a:ea typeface="NanumBarunGothic"/>
-                <a:cs typeface="NanumBarunGothic"/>
-              </a:rPr>
               <a:t>주인공 · 주기적 스파이크</a:t>
             </a:r>
           </a:p>
@@ -8489,14 +8407,14 @@
       </p:sp>
       <p:sp>
         <p:nvSpPr>
-          <p:cNvPr id="16" name="Rounded Rectangle 15"/>
+          <p:cNvPr id="14" name="Rounded Rectangle 13"/>
           <p:cNvSpPr/>
           <p:nvPr/>
         </p:nvSpPr>
         <p:spPr>
           <a:xfrm>
-            <a:off x="502920" y="2834639"/>
-            <a:ext cx="11155680" cy="777240"/>
+            <a:off x="502920" y="2697480"/>
+            <a:ext cx="11155680" cy="658368"/>
           </a:xfrm>
           <a:prstGeom prst="roundRect">
             <a:avLst>
@@ -8536,14 +8454,14 @@
       </p:sp>
       <p:sp>
         <p:nvSpPr>
-          <p:cNvPr id="17" name="TextBox 16"/>
-          <p:cNvSpPr txBox="1"/>
-          <p:nvPr/>
-        </p:nvSpPr>
-        <p:spPr>
-          <a:xfrm>
-            <a:off x="640080" y="3035808"/>
-            <a:ext cx="2651760" cy="411480"/>
+          <p:cNvPr id="15" name="TextBox 14"/>
+          <p:cNvSpPr txBox="1"/>
+          <p:nvPr/>
+        </p:nvSpPr>
+        <p:spPr>
+          <a:xfrm>
+            <a:off x="640080" y="2862072"/>
+            <a:ext cx="3474720" cy="411480"/>
           </a:xfrm>
           <a:prstGeom prst="rect">
             <a:avLst/>
@@ -8570,21 +8488,21 @@
                 <a:ea typeface="NanumBarunGothic"/>
                 <a:cs typeface="NanumBarunGothic"/>
               </a:rPr>
-              <a:t>pump-a-nde</a:t>
-            </a:r>
-          </a:p>
-        </p:txBody>
-      </p:sp>
-      <p:sp>
-        <p:nvSpPr>
-          <p:cNvPr id="18" name="TextBox 17"/>
-          <p:cNvSpPr txBox="1"/>
-          <p:nvPr/>
-        </p:nvSpPr>
-        <p:spPr>
-          <a:xfrm>
-            <a:off x="3383280" y="3035808"/>
-            <a:ext cx="2651760" cy="411480"/>
+              <a:t>압축기실</a:t>
+            </a:r>
+          </a:p>
+        </p:txBody>
+      </p:sp>
+      <p:sp>
+        <p:nvSpPr>
+          <p:cNvPr id="16" name="TextBox 15"/>
+          <p:cNvSpPr txBox="1"/>
+          <p:nvPr/>
+        </p:nvSpPr>
+        <p:spPr>
+          <a:xfrm>
+            <a:off x="4297680" y="2862072"/>
+            <a:ext cx="3474720" cy="411480"/>
           </a:xfrm>
           <a:prstGeom prst="rect">
             <a:avLst/>
@@ -8611,21 +8529,21 @@
                 <a:ea typeface="NanumBarunGothic"/>
                 <a:cs typeface="NanumBarunGothic"/>
               </a:rPr>
-              <a:t>냉각수 펌프 A</a:t>
-            </a:r>
-          </a:p>
-        </p:txBody>
-      </p:sp>
-      <p:sp>
-        <p:nvSpPr>
-          <p:cNvPr id="19" name="TextBox 18"/>
-          <p:cNvSpPr txBox="1"/>
-          <p:nvPr/>
-        </p:nvSpPr>
-        <p:spPr>
-          <a:xfrm>
-            <a:off x="6126480" y="3035808"/>
-            <a:ext cx="2651760" cy="411480"/>
+              <a:t>compressor-c / blower-f</a:t>
+            </a:r>
+          </a:p>
+        </p:txBody>
+      </p:sp>
+      <p:sp>
+        <p:nvSpPr>
+          <p:cNvPr id="17" name="TextBox 16"/>
+          <p:cNvSpPr txBox="1"/>
+          <p:nvPr/>
+        </p:nvSpPr>
+        <p:spPr>
+          <a:xfrm>
+            <a:off x="7955279" y="2862072"/>
+            <a:ext cx="3474720" cy="411480"/>
           </a:xfrm>
           <a:prstGeom prst="rect">
             <a:avLst/>
@@ -8652,62 +8570,21 @@
                 <a:ea typeface="NanumBarunGothic"/>
                 <a:cs typeface="NanumBarunGothic"/>
               </a:rPr>
-              <a:t>비구동측 베어링</a:t>
-            </a:r>
-          </a:p>
-        </p:txBody>
-      </p:sp>
-      <p:sp>
-        <p:nvSpPr>
-          <p:cNvPr id="20" name="TextBox 19"/>
-          <p:cNvSpPr txBox="1"/>
-          <p:nvPr/>
-        </p:nvSpPr>
-        <p:spPr>
-          <a:xfrm>
-            <a:off x="8869680" y="3035808"/>
-            <a:ext cx="2651760" cy="411480"/>
-          </a:xfrm>
-          <a:prstGeom prst="rect">
-            <a:avLst/>
-          </a:prstGeom>
-          <a:noFill/>
-        </p:spPr>
-        <p:txBody>
-          <a:bodyPr wrap="square">
-            <a:spAutoFit/>
-          </a:bodyPr>
-          <a:lstStyle/>
-          <a:p>
-            <a:pPr algn="l">
-              <a:spcAft>
-                <a:spcPts val="0"/>
-              </a:spcAft>
-            </a:pPr>
-            <a:r>
-              <a:rPr sz="1500" b="0">
-                <a:solidFill>
-                  <a:srgbClr val="F8FAFC"/>
-                </a:solidFill>
-                <a:latin typeface="NanumBarunGothic"/>
-                <a:ea typeface="NanumBarunGothic"/>
-                <a:cs typeface="NanumBarunGothic"/>
-              </a:rPr>
-              <a:t>대체로 평온</a:t>
-            </a:r>
-          </a:p>
-        </p:txBody>
-      </p:sp>
-      <p:sp>
-        <p:nvSpPr>
-          <p:cNvPr id="21" name="Rounded Rectangle 20"/>
+              <a:t>유틸리티</a:t>
+            </a:r>
+          </a:p>
+        </p:txBody>
+      </p:sp>
+      <p:sp>
+        <p:nvSpPr>
+          <p:cNvPr id="18" name="Rounded Rectangle 17"/>
           <p:cNvSpPr/>
           <p:nvPr/>
         </p:nvSpPr>
         <p:spPr>
           <a:xfrm>
-            <a:off x="502920" y="3703320"/>
-            <a:ext cx="11155680" cy="777240"/>
+            <a:off x="502920" y="3429000"/>
+            <a:ext cx="11155680" cy="658368"/>
           </a:xfrm>
           <a:prstGeom prst="roundRect">
             <a:avLst>
@@ -8747,14 +8624,14 @@
       </p:sp>
       <p:sp>
         <p:nvSpPr>
-          <p:cNvPr id="22" name="TextBox 21"/>
-          <p:cNvSpPr txBox="1"/>
-          <p:nvPr/>
-        </p:nvSpPr>
-        <p:spPr>
-          <a:xfrm>
-            <a:off x="640080" y="3904487"/>
-            <a:ext cx="2651760" cy="411480"/>
+          <p:cNvPr id="19" name="TextBox 18"/>
+          <p:cNvSpPr txBox="1"/>
+          <p:nvPr/>
+        </p:nvSpPr>
+        <p:spPr>
+          <a:xfrm>
+            <a:off x="640080" y="3593592"/>
+            <a:ext cx="3474720" cy="411480"/>
           </a:xfrm>
           <a:prstGeom prst="rect">
             <a:avLst/>
@@ -8781,21 +8658,21 @@
                 <a:ea typeface="NanumBarunGothic"/>
                 <a:cs typeface="NanumBarunGothic"/>
               </a:rPr>
-              <a:t>fan-b-motor</a:t>
-            </a:r>
-          </a:p>
-        </p:txBody>
-      </p:sp>
-      <p:sp>
-        <p:nvSpPr>
-          <p:cNvPr id="23" name="TextBox 22"/>
-          <p:cNvSpPr txBox="1"/>
-          <p:nvPr/>
-        </p:nvSpPr>
-        <p:spPr>
-          <a:xfrm>
-            <a:off x="3383280" y="3904487"/>
-            <a:ext cx="2651760" cy="411480"/>
+              <a:t>생산 라인</a:t>
+            </a:r>
+          </a:p>
+        </p:txBody>
+      </p:sp>
+      <p:sp>
+        <p:nvSpPr>
+          <p:cNvPr id="20" name="TextBox 19"/>
+          <p:cNvSpPr txBox="1"/>
+          <p:nvPr/>
+        </p:nvSpPr>
+        <p:spPr>
+          <a:xfrm>
+            <a:off x="4297680" y="3593592"/>
+            <a:ext cx="3474720" cy="411480"/>
           </a:xfrm>
           <a:prstGeom prst="rect">
             <a:avLst/>
@@ -8822,21 +8699,21 @@
                 <a:ea typeface="NanumBarunGothic"/>
                 <a:cs typeface="NanumBarunGothic"/>
               </a:rPr>
-              <a:t>HVAC 팬 B</a:t>
-            </a:r>
-          </a:p>
-        </p:txBody>
-      </p:sp>
-      <p:sp>
-        <p:nvSpPr>
-          <p:cNvPr id="24" name="TextBox 23"/>
-          <p:cNvSpPr txBox="1"/>
-          <p:nvPr/>
-        </p:nvSpPr>
-        <p:spPr>
-          <a:xfrm>
-            <a:off x="6126480" y="3904487"/>
-            <a:ext cx="2651760" cy="411480"/>
+              <a:t>conveyor · mixer · press</a:t>
+            </a:r>
+          </a:p>
+        </p:txBody>
+      </p:sp>
+      <p:sp>
+        <p:nvSpPr>
+          <p:cNvPr id="21" name="TextBox 20"/>
+          <p:cNvSpPr txBox="1"/>
+          <p:nvPr/>
+        </p:nvSpPr>
+        <p:spPr>
+          <a:xfrm>
+            <a:off x="7955279" y="3593592"/>
+            <a:ext cx="3474720" cy="411480"/>
           </a:xfrm>
           <a:prstGeom prst="rect">
             <a:avLst/>
@@ -8863,21 +8740,68 @@
                 <a:ea typeface="NanumBarunGothic"/>
                 <a:cs typeface="NanumBarunGothic"/>
               </a:rPr>
-              <a:t>모터 하우징</a:t>
-            </a:r>
-          </a:p>
-        </p:txBody>
-      </p:sp>
-      <p:sp>
-        <p:nvSpPr>
-          <p:cNvPr id="25" name="TextBox 24"/>
-          <p:cNvSpPr txBox="1"/>
-          <p:nvPr/>
-        </p:nvSpPr>
-        <p:spPr>
-          <a:xfrm>
-            <a:off x="8869680" y="3904487"/>
-            <a:ext cx="2651760" cy="411480"/>
+              <a:t>배경 설비 4점</a:t>
+            </a:r>
+          </a:p>
+        </p:txBody>
+      </p:sp>
+      <p:sp>
+        <p:nvSpPr>
+          <p:cNvPr id="22" name="Rounded Rectangle 21"/>
+          <p:cNvSpPr/>
+          <p:nvPr/>
+        </p:nvSpPr>
+        <p:spPr>
+          <a:xfrm>
+            <a:off x="502920" y="4160520"/>
+            <a:ext cx="11155680" cy="658368"/>
+          </a:xfrm>
+          <a:prstGeom prst="roundRect">
+            <a:avLst>
+              <a:gd name="adj" fmla="val 8000"/>
+            </a:avLst>
+          </a:prstGeom>
+          <a:solidFill>
+            <a:srgbClr val="151F33"/>
+          </a:solidFill>
+          <a:ln w="15875">
+            <a:solidFill>
+              <a:srgbClr val="2A3B57"/>
+            </a:solidFill>
+          </a:ln>
+        </p:spPr>
+        <p:style>
+          <a:lnRef idx="1">
+            <a:schemeClr val="accent1"/>
+          </a:lnRef>
+          <a:fillRef idx="3">
+            <a:schemeClr val="accent1"/>
+          </a:fillRef>
+          <a:effectRef idx="2">
+            <a:schemeClr val="accent1"/>
+          </a:effectRef>
+          <a:fontRef idx="minor">
+            <a:schemeClr val="lt1"/>
+          </a:fontRef>
+        </p:style>
+        <p:txBody>
+          <a:bodyPr rtlCol="0" anchor="ctr"/>
+          <a:lstStyle/>
+          <a:p>
+            <a:pPr algn="ctr"/>
+          </a:p>
+        </p:txBody>
+      </p:sp>
+      <p:sp>
+        <p:nvSpPr>
+          <p:cNvPr id="23" name="TextBox 22"/>
+          <p:cNvSpPr txBox="1"/>
+          <p:nvPr/>
+        </p:nvSpPr>
+        <p:spPr>
+          <a:xfrm>
+            <a:off x="640080" y="4325112"/>
+            <a:ext cx="3474720" cy="411480"/>
           </a:xfrm>
           <a:prstGeom prst="rect">
             <a:avLst/>
@@ -8904,21 +8828,21 @@
                 <a:ea typeface="NanumBarunGothic"/>
                 <a:cs typeface="NanumBarunGothic"/>
               </a:rPr>
-              <a:t>대조군</a:t>
-            </a:r>
-          </a:p>
-        </p:txBody>
-      </p:sp>
-      <p:sp>
-        <p:nvSpPr>
-          <p:cNvPr id="26" name="TextBox 25"/>
-          <p:cNvSpPr txBox="1"/>
-          <p:nvPr/>
-        </p:nvSpPr>
-        <p:spPr>
-          <a:xfrm>
-            <a:off x="502920" y="4754880"/>
-            <a:ext cx="11155680" cy="640080"/>
+              <a:t>공조·냉각탑</a:t>
+            </a:r>
+          </a:p>
+        </p:txBody>
+      </p:sp>
+      <p:sp>
+        <p:nvSpPr>
+          <p:cNvPr id="24" name="TextBox 23"/>
+          <p:cNvSpPr txBox="1"/>
+          <p:nvPr/>
+        </p:nvSpPr>
+        <p:spPr>
+          <a:xfrm>
+            <a:off x="4297680" y="4325112"/>
+            <a:ext cx="3474720" cy="411480"/>
           </a:xfrm>
           <a:prstGeom prst="rect">
             <a:avLst/>
@@ -8939,13 +8863,95 @@
             <a:r>
               <a:rPr sz="1500" b="0">
                 <a:solidFill>
-                  <a:srgbClr val="94A3B8"/>
+                  <a:srgbClr val="F8FAFC"/>
                 </a:solidFill>
                 <a:latin typeface="NanumBarunGothic"/>
                 <a:ea typeface="NanumBarunGothic"/>
                 <a:cs typeface="NanumBarunGothic"/>
               </a:rPr>
-              <a:t>ID를 외울 필요는 없습니다. Skill과 슬라이드가 같은 이름을 씁니다.</a:t>
+              <a:t>fan-b-motor / cooling-tower-fan</a:t>
+            </a:r>
+          </a:p>
+        </p:txBody>
+      </p:sp>
+      <p:sp>
+        <p:nvSpPr>
+          <p:cNvPr id="25" name="TextBox 24"/>
+          <p:cNvSpPr txBox="1"/>
+          <p:nvPr/>
+        </p:nvSpPr>
+        <p:spPr>
+          <a:xfrm>
+            <a:off x="7955279" y="4325112"/>
+            <a:ext cx="3474720" cy="411480"/>
+          </a:xfrm>
+          <a:prstGeom prst="rect">
+            <a:avLst/>
+          </a:prstGeom>
+          <a:noFill/>
+        </p:spPr>
+        <p:txBody>
+          <a:bodyPr wrap="square">
+            <a:spAutoFit/>
+          </a:bodyPr>
+          <a:lstStyle/>
+          <a:p>
+            <a:pPr algn="l">
+              <a:spcAft>
+                <a:spcPts val="0"/>
+              </a:spcAft>
+            </a:pPr>
+            <a:r>
+              <a:rPr sz="1500" b="0">
+                <a:solidFill>
+                  <a:srgbClr val="F8FAFC"/>
+                </a:solidFill>
+                <a:latin typeface="NanumBarunGothic"/>
+                <a:ea typeface="NanumBarunGothic"/>
+                <a:cs typeface="NanumBarunGothic"/>
+              </a:rPr>
+              <a:t>대조군</a:t>
+            </a:r>
+          </a:p>
+        </p:txBody>
+      </p:sp>
+      <p:sp>
+        <p:nvSpPr>
+          <p:cNvPr id="26" name="TextBox 25"/>
+          <p:cNvSpPr txBox="1"/>
+          <p:nvPr/>
+        </p:nvSpPr>
+        <p:spPr>
+          <a:xfrm>
+            <a:off x="502920" y="4937760"/>
+            <a:ext cx="11155680" cy="640080"/>
+          </a:xfrm>
+          <a:prstGeom prst="rect">
+            <a:avLst/>
+          </a:prstGeom>
+          <a:noFill/>
+        </p:spPr>
+        <p:txBody>
+          <a:bodyPr wrap="square">
+            <a:spAutoFit/>
+          </a:bodyPr>
+          <a:lstStyle/>
+          <a:p>
+            <a:pPr algn="l">
+              <a:spcAft>
+                <a:spcPts val="0"/>
+              </a:spcAft>
+            </a:pPr>
+            <a:r>
+              <a:rPr sz="1500" b="0">
+                <a:solidFill>
+                  <a:srgbClr val="94A3B8"/>
+                </a:solidFill>
+                <a:latin typeface="NanumBarunGothic"/>
+                <a:ea typeface="NanumBarunGothic"/>
+                <a:cs typeface="NanumBarunGothic"/>
+              </a:rPr>
+              <a:t>지도는 http://localhost:8000 . 외울 ID는 pump-a-de 하나면 됩니다.</a:t>
             </a:r>
           </a:p>
         </p:txBody>
@@ -10229,7 +10235,7 @@
               </a:rPr>
               <a:t>warning  ≥  4.5 mm/s     anomaly  ≥  7.0 mm/s
 이 숫자는 수업용입니다. 현장 기준이 아닙니다.
-더미 센서는 45초마다 pump-a-de를 한 번 스파이크합니다.
+더미 센서는 약 10초마다 이상을 한 번 스파이크합니다.
 데모가 ‘아무 이상 없음’으로 죽지 않게 하려고요.
 탐지 지능을 모델에게 맡기지 않은 것은 의도입니다.</a:t>
             </a:r>
@@ -12668,7 +12674,7 @@
                 <a:ea typeface="NanumBarunGothic"/>
                 <a:cs typeface="NanumBarunGothic"/>
               </a:rPr>
-              <a:t>도구 1</a:t>
+              <a:t>조회</a:t>
             </a:r>
           </a:p>
         </p:txBody>
@@ -12709,7 +12715,7 @@
                 <a:ea typeface="NanumSquare"/>
                 <a:cs typeface="NanumSquare"/>
               </a:rPr>
-              <a:t>list_sensors</a:t>
+              <a:t>list / get</a:t>
             </a:r>
           </a:p>
         </p:txBody>
@@ -12750,7 +12756,7 @@
                 <a:ea typeface="NanumBarunGothic"/>
                 <a:cs typeface="NanumBarunGothic"/>
               </a:rPr>
-              <a:t>뭐가 있나.</a:t>
+              <a:t>assets · sensors · events</a:t>
             </a:r>
           </a:p>
         </p:txBody>
@@ -12881,7 +12887,7 @@
                 <a:ea typeface="NanumBarunGothic"/>
                 <a:cs typeface="NanumBarunGothic"/>
               </a:rPr>
-              <a:t>도구 2</a:t>
+              <a:t>변경(더미)</a:t>
             </a:r>
           </a:p>
         </p:txBody>
@@ -12922,7 +12928,7 @@
                 <a:ea typeface="NanumSquare"/>
                 <a:cs typeface="NanumSquare"/>
               </a:rPr>
-              <a:t>get_vibration_reading</a:t>
+              <a:t>power / fail</a:t>
             </a:r>
           </a:p>
         </p:txBody>
@@ -12963,7 +12969,7 @@
                 <a:ea typeface="NanumBarunGothic"/>
                 <a:cs typeface="NanumBarunGothic"/>
               </a:rPr>
-              <a:t>한 점의 최신 값.</a:t>
+              <a:t>set_asset_power, fail_asset</a:t>
             </a:r>
           </a:p>
         </p:txBody>
@@ -13094,7 +13100,7 @@
                 <a:ea typeface="NanumBarunGothic"/>
                 <a:cs typeface="NanumBarunGothic"/>
               </a:rPr>
-              <a:t>도구 3</a:t>
+              <a:t>교체(더미)</a:t>
             </a:r>
           </a:p>
         </p:txBody>
@@ -13135,7 +13141,7 @@
                 <a:ea typeface="NanumSquare"/>
                 <a:cs typeface="NanumSquare"/>
               </a:rPr>
-              <a:t>get_recent_anomalies</a:t>
+              <a:t>replace_asset</a:t>
             </a:r>
           </a:p>
         </p:txBody>
@@ -13176,7 +13182,7 @@
                 <a:ea typeface="NanumBarunGothic"/>
                 <a:cs typeface="NanumBarunGothic"/>
               </a:rPr>
-              <a:t>최근 이상만.</a:t>
+              <a:t>고장난 인스턴스만.</a:t>
             </a:r>
           </a:p>
         </p:txBody>
@@ -13544,7 +13550,7 @@
 ▸  언제: 이 문서를 꺼내야 하는 질문
 ▸  절차: 도구를 어떤 순서로 부를지
 ▸  출력: 요약 / 근거 / 해석 / 권고 / 한계
-▸  금지: 숫자 발명, 정지 명령, 비밀 키</a:t>
+▸  금지: 숫자 발명, 없는 ID, 실설비를 더미처럼</a:t>
             </a:r>
           </a:p>
         </p:txBody>
@@ -14124,7 +14130,7 @@
                 <a:ea typeface="NanumBarunGothic"/>
                 <a:cs typeface="NanumBarunGothic"/>
               </a:rPr>
-              <a:t>더미 센서</a:t>
+              <a:t>더미 공장</a:t>
             </a:r>
           </a:p>
         </p:txBody>
@@ -14165,8 +14171,8 @@
                 <a:ea typeface="NanumBarunGothic"/>
                 <a:cs typeface="NanumBarunGothic"/>
               </a:rPr>
-              <a:t>Python
-가짜 RMS</a:t>
+              <a:t>생성기
++ SQLite</a:t>
             </a:r>
           </a:p>
         </p:txBody>
@@ -14295,7 +14301,7 @@
                 <a:ea typeface="NanumBarunGothic"/>
                 <a:cs typeface="NanumBarunGothic"/>
               </a:rPr>
-              <a:t>MQTT</a:t>
+              <a:t>MCP</a:t>
             </a:r>
           </a:p>
         </p:txBody>
@@ -14336,8 +14342,8 @@
                 <a:ea typeface="NanumBarunGothic"/>
                 <a:cs typeface="NanumBarunGothic"/>
               </a:rPr>
-              <a:t>Mosquitto
-:1883</a:t>
+              <a:t>조회·변경
+:8000/mcp</a:t>
             </a:r>
           </a:p>
         </p:txBody>
@@ -14466,7 +14472,7 @@
                 <a:ea typeface="NanumBarunGothic"/>
                 <a:cs typeface="NanumBarunGothic"/>
               </a:rPr>
-              <a:t>MCP</a:t>
+              <a:t>지도</a:t>
             </a:r>
           </a:p>
         </p:txBody>
@@ -14507,8 +14513,8 @@
                 <a:ea typeface="NanumBarunGothic"/>
                 <a:cs typeface="NanumBarunGothic"/>
               </a:rPr>
-              <a:t>도구 3개
-:8000/mcp</a:t>
+              <a:t>top-down
+:8000/</a:t>
             </a:r>
           </a:p>
         </p:txBody>
@@ -16012,7 +16018,7 @@
                 <a:ea typeface="NanumBarunGothic"/>
                 <a:cs typeface="NanumBarunGothic"/>
               </a:rPr>
-              <a:t>작은 도구, 그라운딩, 사람 승인</a:t>
+              <a:t>에이전트 vs 과함, 더미 변경 vs 실설비</a:t>
             </a:r>
           </a:p>
         </p:txBody>
@@ -16182,7 +16188,7 @@
                 <a:ea typeface="NanumBarunGothic"/>
                 <a:cs typeface="NanumBarunGothic"/>
               </a:rPr>
-              <a:t>Open WebUI in Codespaces</a:t>
+              <a:t>uv + Open WebUI</a:t>
             </a:r>
           </a:p>
         </p:txBody>
@@ -16223,7 +16229,7 @@
                 <a:ea typeface="NanumBarunGothic"/>
                 <a:cs typeface="NanumBarunGothic"/>
               </a:rPr>
-              <a:t>더미 진동 → MQTT → MCP → 챗봇</a:t>
+              <a:t>더미 공장 → SQLite → MCP → 챗봇</a:t>
             </a:r>
           </a:p>
         </p:txBody>
@@ -18077,7 +18083,7 @@
                 <a:ea typeface="NanumBarunGothic"/>
                 <a:cs typeface="NanumBarunGothic"/>
               </a:rPr>
-              <a:t>하는 쪽</a:t>
+              <a:t>조회</a:t>
             </a:r>
           </a:p>
         </p:txBody>
@@ -18118,7 +18124,7 @@
                 <a:ea typeface="NanumSquare"/>
                 <a:cs typeface="NanumSquare"/>
               </a:rPr>
-              <a:t>오늘 세 개</a:t>
+              <a:t>list / get / events</a:t>
             </a:r>
           </a:p>
         </p:txBody>
@@ -18159,10 +18165,10 @@
                 <a:ea typeface="NanumBarunGothic"/>
                 <a:cs typeface="NanumBarunGothic"/>
               </a:rPr>
-              <a:t>list_sensors
+              <a:t>list_assets
+list_sensors
 get_vibration_reading
-get_recent_anomalies
-읽기만. 최소 권한.</a:t>
+get_recent_events</a:t>
             </a:r>
           </a:p>
         </p:txBody>
@@ -18293,7 +18299,7 @@
                 <a:ea typeface="NanumBarunGothic"/>
                 <a:cs typeface="NanumBarunGothic"/>
               </a:rPr>
-              <a:t>하지 않는 쪽</a:t>
+              <a:t>변경 (더미만)</a:t>
             </a:r>
           </a:p>
         </p:txBody>
@@ -18334,7 +18340,7 @@
                 <a:ea typeface="NanumSquare"/>
                 <a:cs typeface="NanumSquare"/>
               </a:rPr>
-              <a:t>금지 예시</a:t>
+              <a:t>request / power / fail / replace</a:t>
             </a:r>
           </a:p>
         </p:txBody>
@@ -18375,11 +18381,11 @@
                 <a:ea typeface="NanumBarunGothic"/>
                 <a:cs typeface="NanumBarunGothic"/>
               </a:rPr>
-              <a:t>do_everything
-analyze_plant
-stop_pump
-한 도구가 설명+판단+조치를
-다 하면 모델이 거대해집니다.</a:t>
+              <a:t>request_fix  → 화면 수락
+set_asset_power
+fail_asset
+replace_asset
+에이전트는 공구를 잡지 않는다.</a:t>
             </a:r>
           </a:p>
         </p:txBody>
@@ -18982,7 +18988,7 @@
                 <a:ea typeface="NanumBarunGothic"/>
                 <a:cs typeface="NanumBarunGothic"/>
               </a:rPr>
-              <a:t>THEORY 4  ·  SAFETY</a:t>
+              <a:t>THEORY 4  ·  AGENT VS OVERKILL</a:t>
             </a:r>
           </a:p>
         </p:txBody>
@@ -19023,7 +19029,7 @@
                 <a:ea typeface="NanumSquare"/>
                 <a:cs typeface="NanumSquare"/>
               </a:rPr>
-              <a:t>정비 결정은 사람의 권한입니다</a:t>
+              <a:t>에이전트는 언제 쓰고, 언제 과한가</a:t>
             </a:r>
           </a:p>
         </p:txBody>
@@ -19154,7 +19160,7 @@
                 <a:ea typeface="NanumBarunGothic"/>
                 <a:cs typeface="NanumBarunGothic"/>
               </a:rPr>
-              <a:t>모델이 해도 되는 것</a:t>
+              <a:t>맞다</a:t>
             </a:r>
           </a:p>
         </p:txBody>
@@ -19195,7 +19201,7 @@
                 <a:ea typeface="NanumSquare"/>
                 <a:cs typeface="NanumSquare"/>
               </a:rPr>
-              <a:t>설명 · 인용 · 제안</a:t>
+              <a:t>도구를 잇는 일</a:t>
             </a:r>
           </a:p>
         </p:txBody>
@@ -19236,8 +19242,9 @@
                 <a:ea typeface="NanumBarunGothic"/>
                 <a:cs typeface="NanumBarunGothic"/>
               </a:rPr>
-              <a:t>숫자를 읽고 현장 언어로 옮긴다.
-‘확인해 주세요’까지.</a:t>
+              <a:t>목록 → 값 → 고장 → 교체.
+지도만으로 안 끝나는 순서.
+Skill이 변경을 묶어 준다.</a:t>
             </a:r>
           </a:p>
         </p:txBody>
@@ -19368,7 +19375,7 @@
                 <a:ea typeface="NanumBarunGothic"/>
                 <a:cs typeface="NanumBarunGothic"/>
               </a:rPr>
-              <a:t>모델이 하면 안 되는 것</a:t>
+              <a:t>과하다</a:t>
             </a:r>
           </a:p>
         </p:txBody>
@@ -19409,7 +19416,7 @@
                 <a:ea typeface="NanumSquare"/>
                 <a:cs typeface="NanumSquare"/>
               </a:rPr>
-              <a:t>승인 · 기동 · 정지</a:t>
+              <a:t>한 눈이면 되는 일</a:t>
             </a:r>
           </a:p>
         </p:txBody>
@@ -19450,9 +19457,10 @@
                 <a:ea typeface="NanumBarunGothic"/>
                 <a:cs typeface="NanumBarunGothic"/>
               </a:rPr>
-              <a:t>‘정지하세요’ 명령조.
-‘제가 승인했습니다’.
-잠긴 밸브, 안전 절차 생략.</a:t>
+              <a:t>지금 RMS만 보기.
+새로고침.
+실설비 기동/정지를 모델에게.
+그건 계산기지 비서가 아니다.</a:t>
             </a:r>
           </a:p>
         </p:txBody>
@@ -21372,10 +21380,9 @@
               </a:rPr>
               <a:t>☐  예지보전 = 루프. AI는 조치자가 아니다.
 ☐  이상은 수업용 임계값이다. 진단서가 아니다.
-☐  MCP 도구는 세 개. 읽기만.
-☐  Skill은 Markdown 절차서다.
-☐  숫자 대조가 가능해야 한다 (/demo/sensors).
-☐  정지 권한은 사람에게 남긴다.</a:t>
+☐  조회와 변경은 다른 층이다.
+☐  한 숫자 보기에는 에이전트가 과할 수 있다.
+☐  실설비 기동/정지를 모델에게 주면 위험하다.</a:t>
             </a:r>
           </a:p>
         </p:txBody>
@@ -21651,7 +21658,7 @@
                 <a:ea typeface="NanumSquare"/>
                 <a:cs typeface="NanumSquare"/>
               </a:rPr>
-              <a:t>실습: Codespaces와 Open WebUI</a:t>
+              <a:t>실습: uv와 Open WebUI</a:t>
             </a:r>
           </a:p>
         </p:txBody>
@@ -21968,7 +21975,7 @@
                 <a:ea typeface="NanumSquare"/>
                 <a:cs typeface="NanumSquare"/>
               </a:rPr>
-              <a:t>한 명령으로 네 컨테이너</a:t>
+              <a:t>uv로 공장과 챗봇</a:t>
             </a:r>
           </a:p>
         </p:txBody>
@@ -22048,7 +22055,7 @@
               </a:spcAft>
             </a:pPr>
             <a:r>
-              <a:rPr sz="1800" b="0">
+              <a:rPr sz="1600" b="0">
                 <a:solidFill>
                   <a:srgbClr val="34D399"/>
                 </a:solidFill>
@@ -22057,9 +22064,9 @@
                 <a:cs typeface="NanumGothicCoding"/>
               </a:rPr>
               <a:t>cd playground
-cp .env.example .env    # 키는 여기에만
-./scripts/up.sh
-curl -s http://localhost:8000/health</a:t>
+copy .env.example .env          # 키는 여기에만
+uv run --python 3.12 --env-file .env python mcp-server/server.py
+# 다른 터미널: README의 Open WebUI 한 줄</a:t>
             </a:r>
           </a:p>
         </p:txBody>
@@ -22100,8 +22107,8 @@
                 <a:ea typeface="NanumBarunGothic"/>
                 <a:cs typeface="NanumBarunGothic"/>
               </a:rPr>
-              <a:t>성공: mosquitto · dummy-sensor · mcp-server :8000 · open-webui :8080
-Codespaces는 Ports 탭에서 8080을 엽니다. 로컬 Docker가 막히면 Codespaces로 즉시 이동.</a:t>
+              <a:t>성공: 공장 :8000 (지도+SQLite+MCP) · Open WebUI :8080
+설치·키·실행은 README. Docker 없음.</a:t>
             </a:r>
           </a:p>
         </p:txBody>
@@ -23018,7 +23025,7 @@
                 <a:ea typeface="NanumBarunGothic"/>
                 <a:cs typeface="NanumBarunGothic"/>
               </a:rPr>
-              <a:t>MQTT+MCP는 키가 없어도 뜹니다.
+              <a:t>공장+MCP는 키가 없어도 뜹니다.
 챗봇만 비어 있습니다.</a:t>
             </a:r>
           </a:p>
@@ -24152,7 +24159,7 @@
                 <a:cs typeface="NanumBarunGothic"/>
               </a:rPr>
               <a:t>펌프가 정말 아픈 것이 아닙니다.
-45초마다 스파이크를 넣었습니다.</a:t>
+10초마다 스파이크를 넣었습니다.</a:t>
             </a:r>
           </a:p>
         </p:txBody>
@@ -24518,7 +24525,7 @@
               </a:rPr>
               <a:t>1.  Admin → Integrations → Add Server
 2.  타입: MCP (Streamable HTTP)  ← OpenAPI 아님
-3.  URL: http://mcp-server:8000/mcp  (컨테이너 안)
+3.  URL: http://127.0.0.1:8000/mcp
 4.  Auth: None  (빈 Bearer 금지)
 5.  채팅에서 MCP 토글 ON
 6.  skills/vibration-pdm.md 전체를 Skills 또는 Prompts에 복사</a:t>
@@ -25184,7 +25191,7 @@
                 <a:ea typeface="NanumBarunGothic"/>
                 <a:cs typeface="NanumBarunGothic"/>
               </a:rPr>
-              <a:t>최근 이상 요약. 정지 여부는 당신이 결정하지 말고, 사람이 확인한다고 적을 것.</a:t>
+              <a:t>최근 이벤트 인용. 이상만이 아니라 power/fail도 될 수 있음.</a:t>
             </a:r>
           </a:p>
         </p:txBody>
@@ -27179,7 +27186,7 @@
               </a:rPr>
               <a:t>1. 챗봇은 센서가 아니다. MCP 도구가 센서다.
 2. 도구가 있어도 모델은 거짓말한다. Markdown Skill이 절차를 고정한다.
-3. 정비 시작/정지는 사람의 권한이다.</a:t>
+3. 한 숫자 조회는 과할 수 있다. 실설비 변경은 위험하다.</a:t>
             </a:r>
           </a:p>
         </p:txBody>
@@ -27777,7 +27784,7 @@
                 <a:ea typeface="NanumSquare"/>
                 <a:cs typeface="NanumSquare"/>
               </a:rPr>
-              <a:t>compose</a:t>
+              <a:t>uv</a:t>
             </a:r>
           </a:p>
         </p:txBody>
@@ -28905,7 +28912,7 @@
                 <a:ea typeface="NanumBarunGothic"/>
                 <a:cs typeface="NanumBarunGothic"/>
               </a:rPr>
-              <a:t>결정은 사람 것이다</a:t>
+              <a:t>에이전트는 가려 쓴다</a:t>
             </a:r>
           </a:p>
         </p:txBody>
@@ -28946,7 +28953,7 @@
                 <a:ea typeface="NanumBarunGothic"/>
                 <a:cs typeface="NanumBarunGothic"/>
               </a:rPr>
-              <a:t>정지·분해를 모델에게 승인 권한으로 주지 않는다.</a:t>
+              <a:t>한 숫자 조회는 과할 수 있다. 도구를 이을 때 맞다. 실설비 변경은 위험.</a:t>
             </a:r>
           </a:p>
         </p:txBody>
@@ -31214,7 +31221,7 @@
                 <a:ea typeface="NanumSquare"/>
                 <a:cs typeface="NanumSquare"/>
               </a:rPr>
-              <a:t>2 전달</a:t>
+              <a:t>2 기록</a:t>
             </a:r>
           </a:p>
         </p:txBody>
@@ -31255,8 +31262,8 @@
                 <a:ea typeface="NanumBarunGothic"/>
                 <a:cs typeface="NanumBarunGothic"/>
               </a:rPr>
-              <a:t>MQTT
-메시지 버스</a:t>
+              <a:t>SQLite
+파일 DB</a:t>
             </a:r>
           </a:p>
         </p:txBody>
@@ -31470,7 +31477,7 @@
                 <a:cs typeface="NanumBarunGothic"/>
               </a:rPr>
               <a:t>MCP
-도구 3개</a:t>
+읽기 도구</a:t>
             </a:r>
           </a:p>
         </p:txBody>
@@ -31856,7 +31863,7 @@
                 <a:ea typeface="NanumSquare"/>
                 <a:cs typeface="NanumSquare"/>
               </a:rPr>
-              <a:t>5 결정</a:t>
+              <a:t>5 조치</a:t>
             </a:r>
           </a:p>
         </p:txBody>
@@ -31897,8 +31904,8 @@
                 <a:ea typeface="NanumBarunGothic"/>
                 <a:cs typeface="NanumBarunGothic"/>
               </a:rPr>
-              <a:t>사람
-기동/정지</a:t>
+              <a:t>더미/사람
+on·fail·replace</a:t>
             </a:r>
           </a:p>
         </p:txBody>
@@ -31939,7 +31946,7 @@
                 <a:ea typeface="NanumBarunGothic"/>
                 <a:cs typeface="NanumBarunGothic"/>
               </a:rPr>
-              <a:t>챗봇은 4번입니다. 5번을 챗봇에게 주면 오늘 설계가 실패한 것입니다.</a:t>
+              <a:t>챗봇은 4번입니다. 5번의 실설비 기동/정지를 챗봇에게 주면 설계가 실패한 것입니다.</a:t>
             </a:r>
           </a:p>
         </p:txBody>

</xml_diff>

<commit_message>
Switch the workshop chatbot from Open WebUI to Claude Desktop MCP.
Co-authored-by: Cursor <cursoragent@cursor.com>
</commit_message>
<xml_diff>
--- a/slides/예지보전_에이전트_실습.pptx
+++ b/slides/예지보전_에이전트_실습.pptx
@@ -2247,7 +2247,7 @@
               <a:rPr sz="1200">
                 <a:latin typeface="NanumBarunGothic"/>
               </a:rPr>
-              <a:t>5분. 키를 공유하지 말 것(한도).</a:t>
+              <a:t>5분. 계정 없으면 JSON으로. 키를 나눠 주지 말 것.</a:t>
             </a:r>
           </a:p>
         </p:txBody>
@@ -2409,7 +2409,7 @@
               <a:rPr sz="1200">
                 <a:latin typeface="NanumBarunGothic"/>
               </a:rPr>
-              <a:t>15분. 화면을 천천히. 타입이 Streamable HTTP인지 확인.</a:t>
+              <a:t>15분. 화면을 천천히. dummy-plant가 Developer에 있는지 확인.</a:t>
             </a:r>
           </a:p>
         </p:txBody>
@@ -6355,7 +6355,7 @@
                 <a:ea typeface="NanumBarunGothic"/>
                 <a:cs typeface="NanumBarunGothic"/>
               </a:rPr>
-              <a:t>SENSOR AGENT TUTORIAL  ·  OPEN WEBUI × MCP × MARKDOWN SKILLS</a:t>
+              <a:t>SENSOR AGENT TUTORIAL  ·  CLAUDE DESKTOP × MCP × MARKDOWN SKILLS</a:t>
             </a:r>
           </a:p>
         </p:txBody>
@@ -6865,7 +6865,7 @@
                 <a:ea typeface="NanumBarunGothic"/>
                 <a:cs typeface="NanumBarunGothic"/>
               </a:rPr>
-              <a:t>MCP :8000  →  Open WebUI :8080
+              <a:t>MCP stdio  →  Claude Desktop
 MQTT 없음.</a:t>
             </a:r>
           </a:p>
@@ -7080,7 +7080,7 @@
                 <a:cs typeface="NanumBarunGothic"/>
               </a:rPr>
               <a:t>실제 정비 절차가 아닙니다.
-무료 한도와 관리자 비용을 같이 봅니다.</a:t>
+조회만이면 지도로도 충분합니다.</a:t>
             </a:r>
           </a:p>
         </p:txBody>
@@ -12501,7 +12501,7 @@
                 <a:ea typeface="NanumSquare"/>
                 <a:cs typeface="NanumSquare"/>
               </a:rPr>
-              <a:t>Streamable HTTP</a:t>
+              <a:t>stdio</a:t>
             </a:r>
           </a:p>
         </p:txBody>
@@ -12542,8 +12542,9 @@
                 <a:ea typeface="NanumBarunGothic"/>
                 <a:cs typeface="NanumBarunGothic"/>
               </a:rPr>
-              <a:t>Open WebUI 네이티브 MCP는 SSE/stdio가 아닙니다.
-URL은 /mcp .</a:t>
+              <a:t>Claude Desktop은 JSON 설정으로
+로컬 프로세스를 붙입니다.
+명령은 `uv run plant-mcp`.</a:t>
             </a:r>
           </a:p>
         </p:txBody>
@@ -13763,8 +13764,8 @@
                 <a:ea typeface="NanumBarunGothic"/>
                 <a:cs typeface="NanumBarunGothic"/>
               </a:rPr>
-              <a:t>Open WebUI Python Function으로
-도구를 만들지 않습니다.
+              <a:t>로컬 Python Tool을 만들지
+않습니다.
 운영팀이 파이썬을 안 고쳐도
 문장을 고치면 행동이 바뀝니다.</a:t>
             </a:r>
@@ -14343,7 +14344,7 @@
                 <a:cs typeface="NanumBarunGothic"/>
               </a:rPr>
               <a:t>조회·변경
-:8000/mcp</a:t>
+plant-mcp</a:t>
             </a:r>
           </a:p>
         </p:txBody>
@@ -14643,7 +14644,7 @@
                 <a:ea typeface="NanumBarunGothic"/>
                 <a:cs typeface="NanumBarunGothic"/>
               </a:rPr>
-              <a:t>Open WebUI</a:t>
+              <a:t>Claude</a:t>
             </a:r>
           </a:p>
         </p:txBody>
@@ -14684,8 +14685,8 @@
                 <a:ea typeface="NanumBarunGothic"/>
                 <a:cs typeface="NanumBarunGothic"/>
               </a:rPr>
-              <a:t>챗봇
-:8080</a:t>
+              <a:t>Desktop
+stdio MCP</a:t>
             </a:r>
           </a:p>
         </p:txBody>
@@ -14814,7 +14815,7 @@
                 <a:ea typeface="NanumBarunGothic"/>
                 <a:cs typeface="NanumBarunGothic"/>
               </a:rPr>
-              <a:t>LLM</a:t>
+              <a:t>Skill</a:t>
             </a:r>
           </a:p>
         </p:txBody>
@@ -14855,8 +14856,8 @@
                 <a:ea typeface="NanumBarunGothic"/>
                 <a:cs typeface="NanumBarunGothic"/>
               </a:rPr>
-              <a:t>무료 티어
-OpenAI 호환</a:t>
+              <a:t>Markdown
+붙여 넣기</a:t>
             </a:r>
           </a:p>
         </p:txBody>
@@ -14897,8 +14898,8 @@
                 <a:ea typeface="NanumBarunGothic"/>
                 <a:cs typeface="NanumBarunGothic"/>
               </a:rPr>
-              <a:t>Skill Markdown은 Open WebUI 쪽에 붙습니다.
-센서 경로와 모델 경로가 분리되어 있어야, 모델이 죽어도 JSON으로 수업을 이어 갑니다.</a:t>
+              <a:t>Skill Markdown은 Claude Desktop 쪽에 붙습니다.
+센서 경로와 모델 경로가 분리되어 있어야, 챗봇이 죽어도 JSON으로 수업을 이어 갑니다.</a:t>
             </a:r>
           </a:p>
         </p:txBody>
@@ -16188,7 +16189,7 @@
                 <a:ea typeface="NanumBarunGothic"/>
                 <a:cs typeface="NanumBarunGothic"/>
               </a:rPr>
-              <a:t>uv + Open WebUI</a:t>
+              <a:t>uv + Claude Desktop</a:t>
             </a:r>
           </a:p>
         </p:txBody>
@@ -20162,7 +20163,7 @@
                 <a:ea typeface="NanumBarunGothic"/>
                 <a:cs typeface="NanumBarunGothic"/>
               </a:rPr>
-              <a:t>API 키를 Skill에 붙여 넣기</a:t>
+              <a:t>키나 경로를 Skill에 붙여 넣기</a:t>
             </a:r>
           </a:p>
         </p:txBody>
@@ -20334,7 +20335,7 @@
                 <a:ea typeface="NanumSquare"/>
                 <a:cs typeface="NanumSquare"/>
               </a:rPr>
-              <a:t>Python Skill</a:t>
+              <a:t>Python Tool</a:t>
             </a:r>
           </a:p>
         </p:txBody>
@@ -20375,7 +20376,7 @@
                 <a:ea typeface="NanumBarunGothic"/>
                 <a:cs typeface="NanumBarunGothic"/>
               </a:rPr>
-              <a:t>오늘 범위 밖 Function</a:t>
+              <a:t>오늘 범위 밖 로컬 도구</a:t>
             </a:r>
           </a:p>
         </p:txBody>
@@ -20547,7 +20548,7 @@
                 <a:ea typeface="NanumSquare"/>
                 <a:cs typeface="NanumSquare"/>
               </a:rPr>
-              <a:t>빈 Bearer</a:t>
+              <a:t>상대 경로 uv</a:t>
             </a:r>
           </a:p>
         </p:txBody>
@@ -20588,7 +20589,7 @@
                 <a:ea typeface="NanumBarunGothic"/>
                 <a:cs typeface="NanumBarunGothic"/>
               </a:rPr>
-              <a:t>MCP 인증 None이 정답</a:t>
+              <a:t>Claude는 PATH를 못 볼 수 있음</a:t>
             </a:r>
           </a:p>
         </p:txBody>
@@ -21658,7 +21659,7 @@
                 <a:ea typeface="NanumSquare"/>
                 <a:cs typeface="NanumSquare"/>
               </a:rPr>
-              <a:t>실습: uv와 Open WebUI</a:t>
+              <a:t>실습: uv와 Claude Desktop</a:t>
             </a:r>
           </a:p>
         </p:txBody>
@@ -21975,7 +21976,7 @@
                 <a:ea typeface="NanumSquare"/>
                 <a:cs typeface="NanumSquare"/>
               </a:rPr>
-              <a:t>uv로 공장과 챗봇</a:t>
+              <a:t>uv로 공장, Claude로 챗봇</a:t>
             </a:r>
           </a:p>
         </p:txBody>
@@ -22064,9 +22065,9 @@
                 <a:cs typeface="NanumGothicCoding"/>
               </a:rPr>
               <a:t>cd playground
-copy .env.example .env          # 키는 여기에만
-uv run --python 3.12 --env-file .env python mcp-server/server.py
-# 다른 터미널: README의 Open WebUI 한 줄</a:t>
+copy .env.example .env
+uv run plant
+uv run claude-config</a:t>
             </a:r>
           </a:p>
         </p:txBody>
@@ -22107,8 +22108,8 @@
                 <a:ea typeface="NanumBarunGothic"/>
                 <a:cs typeface="NanumBarunGothic"/>
               </a:rPr>
-              <a:t>성공: 공장 :8000 (지도+SQLite+MCP) · Open WebUI :8080
-설치·키·실행은 README. Docker 없음.</a:t>
+              <a:t>성공: 공장 :8000 · Claude Desktop에 dummy-plant.
+Claude는 트레이까지 종료 후 재실행. Docker 없음. API 키 없음.</a:t>
             </a:r>
           </a:p>
         </p:txBody>
@@ -22384,7 +22385,7 @@
                 <a:ea typeface="NanumSquare"/>
                 <a:cs typeface="NanumSquare"/>
               </a:rPr>
-              <a:t>무료 티어는 OpenAI 호환 URL만 맞으면 됩니다</a:t>
+              <a:t>챗봇은 Claude Desktop 계정입니다</a:t>
             </a:r>
           </a:p>
         </p:txBody>
@@ -22515,7 +22516,7 @@
                 <a:ea typeface="NanumBarunGothic"/>
                 <a:cs typeface="NanumBarunGothic"/>
               </a:rPr>
-              <a:t>Groq</a:t>
+              <a:t>Claude</a:t>
             </a:r>
           </a:p>
         </p:txBody>
@@ -22556,7 +22557,7 @@
                 <a:ea typeface="NanumSquare"/>
                 <a:cs typeface="NanumSquare"/>
               </a:rPr>
-              <a:t>예시 기본값</a:t>
+              <a:t>실습 기본값</a:t>
             </a:r>
           </a:p>
         </p:txBody>
@@ -22597,8 +22598,8 @@
                 <a:ea typeface="NanumBarunGothic"/>
                 <a:cs typeface="NanumBarunGothic"/>
               </a:rPr>
-              <a:t>BASE https://api.groq.com/openai/v1
-모델은 .env.example 주석.</a:t>
+              <a:t>Desktop 설치 후 로그인.
+API 키를 .env에 넣지 않습니다.</a:t>
             </a:r>
           </a:p>
         </p:txBody>
@@ -22729,7 +22730,7 @@
                 <a:ea typeface="NanumBarunGothic"/>
                 <a:cs typeface="NanumBarunGothic"/>
               </a:rPr>
-              <a:t>그 외</a:t>
+              <a:t>MCP</a:t>
             </a:r>
           </a:p>
         </p:txBody>
@@ -22770,7 +22771,7 @@
                 <a:ea typeface="NanumSquare"/>
                 <a:cs typeface="NanumSquare"/>
               </a:rPr>
-              <a:t>OpenRouter · Gemini</a:t>
+              <a:t>stdio</a:t>
             </a:r>
           </a:p>
         </p:txBody>
@@ -22811,8 +22812,8 @@
                 <a:ea typeface="NanumBarunGothic"/>
                 <a:cs typeface="NanumBarunGothic"/>
               </a:rPr>
-              <a:t>형식이 OpenAI면 됩니다.
-키는 저장소에 없습니다.</a:t>
+              <a:t>uv run claude-config
+가 절대 경로를 씁니다.</a:t>
             </a:r>
           </a:p>
         </p:txBody>
@@ -22943,7 +22944,7 @@
                 <a:ea typeface="NanumBarunGothic"/>
                 <a:cs typeface="NanumBarunGothic"/>
               </a:rPr>
-              <a:t>키 없음</a:t>
+              <a:t>계정 없음</a:t>
             </a:r>
           </a:p>
         </p:txBody>
@@ -23025,8 +23026,8 @@
                 <a:ea typeface="NanumBarunGothic"/>
                 <a:cs typeface="NanumBarunGothic"/>
               </a:rPr>
-              <a:t>공장+MCP는 키가 없어도 뜹니다.
-챗봇만 비어 있습니다.</a:t>
+              <a:t>공장 지도는 계정 없이 뜹니다.
+챗봇만 짝/진행자 화면.</a:t>
             </a:r>
           </a:p>
         </p:txBody>
@@ -24435,7 +24436,7 @@
                 <a:ea typeface="NanumSquare"/>
                 <a:cs typeface="NanumSquare"/>
               </a:rPr>
-              <a:t>MCP는 Streamable HTTP, Skill은 붙여 넣기</a:t>
+              <a:t>MCP는 claude-config, Skill은 붙여 넣기</a:t>
             </a:r>
           </a:p>
         </p:txBody>
@@ -24523,12 +24524,12 @@
                 <a:ea typeface="NanumBarunGothic"/>
                 <a:cs typeface="NanumBarunGothic"/>
               </a:rPr>
-              <a:t>1.  Admin → Integrations → Add Server
-2.  타입: MCP (Streamable HTTP)  ← OpenAPI 아님
-3.  URL: http://127.0.0.1:8000/mcp
-4.  Auth: None  (빈 Bearer 금지)
-5.  채팅에서 MCP 토글 ON
-6.  skills/vibration-pdm.md 전체를 Skills 또는 Prompts에 복사</a:t>
+              <a:t>1.  playground에서 uv run claude-config
+2.  Claude Desktop을 트레이까지 종료 후 재실행
+3.  Settings → Developer 에 dummy-plant
+4.  도구가 안 보이면 uv 절대 경로를 확인
+5.  공장 터미널은 uv run plant 유지
+6.  skills/vibration-pdm.md 전체를 프로젝트 지시 또는 첫 메시지에 복사</a:t>
             </a:r>
           </a:p>
         </p:txBody>
@@ -26560,7 +26561,7 @@
                 <a:ea typeface="NanumSquare"/>
                 <a:cs typeface="NanumSquare"/>
               </a:rPr>
-              <a:t>무료 티어 속도 제한</a:t>
+              <a:t>도구가 안 보임</a:t>
             </a:r>
           </a:p>
         </p:txBody>
@@ -26601,10 +26602,10 @@
                 <a:ea typeface="NanumBarunGothic"/>
                 <a:cs typeface="NanumBarunGothic"/>
               </a:rPr>
-              <a:t>429, 빈 답, ‘잠시 후’.
-창피하지 않습니다.
-curl JSON으로 수업을 잇습니다.
-공유 키 하나는 더 빨리 죽습니다.</a:t>
+              <a:t>claude-config 후
+Claude를 트레이까지 종료.
+uv는 절대 경로.
+공장은 다른 터미널에서 유지.</a:t>
             </a:r>
           </a:p>
         </p:txBody>
@@ -26776,7 +26777,7 @@
                 <a:ea typeface="NanumSquare"/>
                 <a:cs typeface="NanumSquare"/>
               </a:rPr>
-              <a:t>Open WebUI 관리자 부담</a:t>
+              <a:t>계정·설치 부담</a:t>
             </a:r>
           </a:p>
         </p:txBody>
@@ -26817,10 +26818,9 @@
                 <a:ea typeface="NanumBarunGothic"/>
                 <a:cs typeface="NanumBarunGothic"/>
               </a:rPr>
-              <a:t>MCP 추가는 관리자 메뉴.
-첫 가입자=관리자, 비밀번호 분실.
-워크숍은 WEBUI_AUTH=false.
-사내 개방망에 그대로 두지 말 것.</a:t>
+              <a:t>Desktop이 없으면 JSON으로.
+사내 PC에 설치 정책이 있을 수 있음.
+공장 지도는 계정 없이 뜹니다.</a:t>
             </a:r>
           </a:p>
         </p:txBody>

</xml_diff>